<commit_message>
C5·U4 sweep-fix: §4-nummeringsgat gedicht (Lectura §5→§4 in cursus/PDF/PPTX — was kopieerrest uit U3) + València-spelling geüniformeerd (ook voorbeeldzinnen woordenschat). Kaart-klikbaarheid geverifieerd (JS-listener op data-c, geen bug)
</commit_message>
<xml_diff>
--- a/03-build/pptx/C5_U4_alumno.pptx
+++ b/03-build/pptx/C5_U4_alumno.pptx
@@ -4475,7 +4475,7 @@
                 </a:solidFill>
                 <a:latin typeface="Inter"/>
               </a:rPr>
-              <a:t>§5 · ESCUCHAR</a:t>
+              <a:t>§4 · ESCUCHAR</a:t>
             </a:r>
           </a:p>
         </p:txBody>
@@ -4520,7 +4520,7 @@
                 </a:solidFill>
                 <a:latin typeface="Bricolage Grotesque"/>
               </a:rPr>
-              <a:t>5</a:t>
+              <a:t>4</a:t>
             </a:r>
           </a:p>
         </p:txBody>
@@ -29354,7 +29354,7 @@
                 </a:solidFill>
                 <a:latin typeface="Bricolage Grotesque"/>
               </a:rPr>
-              <a:t>§5</a:t>
+              <a:t>§4</a:t>
             </a:r>
           </a:p>
         </p:txBody>
@@ -47319,7 +47319,7 @@
                 </a:solidFill>
                 <a:latin typeface="Inter"/>
               </a:rPr>
-              <a:t>§5 · LEER · COMPRENSIÓN</a:t>
+              <a:t>§4 · LEER · COMPRENSIÓN</a:t>
             </a:r>
           </a:p>
         </p:txBody>
@@ -47364,7 +47364,7 @@
                 </a:solidFill>
                 <a:latin typeface="Bricolage Grotesque"/>
               </a:rPr>
-              <a:t>5</a:t>
+              <a:t>4</a:t>
             </a:r>
           </a:p>
         </p:txBody>

</xml_diff>